<commit_message>
Actualiza presentación con link al repositorio
</commit_message>
<xml_diff>
--- a/CASEN2024_presentacion.pptx
+++ b/CASEN2024_presentacion.pptx
@@ -2535,6 +2535,45 @@
               <a:t>Grupo 2  ·  Andrea Chasi, Pablo Ortiz, Santiago Soler</a:t>
             </a:r>
             <a:endParaRPr lang="en-US" sz="1200" dirty="0"/>
+          </a:p>
+        </p:txBody>
+      </p:sp>
+      <p:sp>
+        <p:nvSpPr>
+          <p:cNvPr id="11" name="Text 9"/>
+          <p:cNvSpPr/>
+          <p:nvPr/>
+        </p:nvSpPr>
+        <p:spPr>
+          <a:xfrm>
+            <a:off x="731520" y="6446520"/>
+            <a:ext cx="9144000" cy="274320"/>
+          </a:xfrm>
+          <a:prstGeom prst="rect">
+            <a:avLst/>
+          </a:prstGeom>
+          <a:noFill/>
+          <a:ln/>
+        </p:spPr>
+        <p:txBody>
+          <a:bodyPr wrap="square" rtlCol="0" anchor="ctr"/>
+          <a:lstStyle/>
+          <a:p>
+            <a:pPr indent="0" marL="0">
+              <a:buNone/>
+            </a:pPr>
+            <a:r>
+              <a:rPr lang="en-US" sz="1050" dirty="0">
+                <a:solidFill>
+                  <a:srgbClr val="7C93A8"/>
+                </a:solidFill>
+                <a:latin typeface="Calibri" pitchFamily="34" charset="0"/>
+                <a:ea typeface="Calibri" pitchFamily="34" charset="-122"/>
+                <a:cs typeface="Calibri" pitchFamily="34" charset="-120"/>
+              </a:rPr>
+              <a:t>Repositorio: github.com/santimsoler/AplicacionFinal_Programacion_UBA</a:t>
+            </a:r>
+            <a:endParaRPr lang="en-US" sz="1050" dirty="0"/>
           </a:p>
         </p:txBody>
       </p:sp>

</xml_diff>